<commit_message>
task-27: shift title zone for 2-line wraps (path c, v0.7.0)
Move red accent line from y=0.500 to y=0.850 so the 0.85in title box
introduced in TASK-24 can host 1-line and 2-line wraps with valign=top
without crossing the line. Subtitle moves to y=0.90 h=0.18 (under the
line), content area starts at y=1.10.

Resolves the v0.6.1 regression where 24pt titles centered in a 0.85in
box dropped baselines below the y=0.500 line and subtitle at y=0.78
overlapped content at y=0.787.

Bump plugin version 0.6.1 -> 0.7.0 (minor, breaking for consumers
already on the v0.6.x y=0.78 subtitle).

Fixture gen_fixtures.js updated and all fixtures regenerated. Added
edge/title-zone-smoke-test.pptx with 1-line and 2-line title slides
plus a pytest assertion that title bottom-y does not cross red line
top-y and subtitle range does not overlap content range.
</commit_message>
<xml_diff>
--- a/plugins/presentation/skills/pptx-arch-style/scripts/tests/fixtures/edge/decision-tree-orthogonal-clean.pptx
+++ b/plugins/presentation/skills/pptx-arch-style/scripts/tests/fixtures/edge/decision-tree-orthogonal-clean.pptx
@@ -1270,7 +1270,7 @@
         </p:nvSpPr>
         <p:spPr>
           <a:xfrm>
-            <a:off x="0" y="457200"/>
+            <a:off x="0" y="777240"/>
             <a:ext cx="9144000" cy="38405"/>
           </a:xfrm>
           <a:prstGeom prst="rect">
@@ -1291,7 +1291,7 @@
         <p:spPr>
           <a:xfrm>
             <a:off x="685800" y="0"/>
-            <a:ext cx="8443570" cy="572414"/>
+            <a:ext cx="8443570" cy="777240"/>
           </a:xfrm>
           <a:prstGeom prst="rect">
             <a:avLst/>
@@ -1300,7 +1300,7 @@
           <a:ln/>
         </p:spPr>
         <p:txBody>
-          <a:bodyPr wrap="square" rtlCol="0" anchor="ctr"/>
+          <a:bodyPr wrap="square" rtlCol="0" anchor="t"/>
           <a:lstStyle/>
           <a:p>
             <a:pPr algn="l" indent="0" marL="0">
@@ -1329,7 +1329,7 @@
         </p:nvSpPr>
         <p:spPr>
           <a:xfrm>
-            <a:off x="548640" y="822960"/>
+            <a:off x="548640" y="1005840"/>
             <a:ext cx="8046720" cy="457200"/>
           </a:xfrm>
           <a:prstGeom prst="rect">

</xml_diff>